<commit_message>
Add new CSV for backup tool strings and refactor main app logic for improved error handling and UI updates.
</commit_message>
<xml_diff>
--- a/Reiri DB Backup Tool - System Design.pptx
+++ b/Reiri DB Backup Tool - System Design.pptx
@@ -2,30 +2,30 @@
 <file path=ppt/presentation.xml><?xml version="1.0" encoding="utf-8"?>
 <p:presentation xmlns:a="http://schemas.openxmlformats.org/drawingml/2006/main" xmlns:r="http://schemas.openxmlformats.org/officeDocument/2006/relationships" xmlns:p="http://schemas.openxmlformats.org/presentationml/2006/main" saveSubsetFonts="1" autoCompressPictures="0">
   <p:sldMasterIdLst>
-    <p:sldMasterId id="2147483648" r:id="rId1"/>
+    <p:sldMasterId id="2147483648" r:id="rId4"/>
   </p:sldMasterIdLst>
   <p:sldIdLst>
-    <p:sldId id="256" r:id="rId2"/>
-    <p:sldId id="257" r:id="rId3"/>
-    <p:sldId id="258" r:id="rId4"/>
-    <p:sldId id="277" r:id="rId5"/>
-    <p:sldId id="271" r:id="rId6"/>
-    <p:sldId id="278" r:id="rId7"/>
-    <p:sldId id="264" r:id="rId8"/>
-    <p:sldId id="279" r:id="rId9"/>
-    <p:sldId id="259" r:id="rId10"/>
-    <p:sldId id="273" r:id="rId11"/>
-    <p:sldId id="263" r:id="rId12"/>
-    <p:sldId id="265" r:id="rId13"/>
-    <p:sldId id="267" r:id="rId14"/>
-    <p:sldId id="260" r:id="rId15"/>
-    <p:sldId id="272" r:id="rId16"/>
-    <p:sldId id="276" r:id="rId17"/>
-    <p:sldId id="262" r:id="rId18"/>
-    <p:sldId id="261" r:id="rId19"/>
-    <p:sldId id="268" r:id="rId20"/>
-    <p:sldId id="269" r:id="rId21"/>
-    <p:sldId id="270" r:id="rId22"/>
+    <p:sldId id="256" r:id="rId5"/>
+    <p:sldId id="257" r:id="rId6"/>
+    <p:sldId id="258" r:id="rId7"/>
+    <p:sldId id="277" r:id="rId8"/>
+    <p:sldId id="271" r:id="rId9"/>
+    <p:sldId id="278" r:id="rId10"/>
+    <p:sldId id="264" r:id="rId11"/>
+    <p:sldId id="279" r:id="rId12"/>
+    <p:sldId id="259" r:id="rId13"/>
+    <p:sldId id="273" r:id="rId14"/>
+    <p:sldId id="263" r:id="rId15"/>
+    <p:sldId id="265" r:id="rId16"/>
+    <p:sldId id="267" r:id="rId17"/>
+    <p:sldId id="260" r:id="rId18"/>
+    <p:sldId id="272" r:id="rId19"/>
+    <p:sldId id="276" r:id="rId20"/>
+    <p:sldId id="262" r:id="rId21"/>
+    <p:sldId id="261" r:id="rId22"/>
+    <p:sldId id="268" r:id="rId23"/>
+    <p:sldId id="269" r:id="rId24"/>
+    <p:sldId id="270" r:id="rId25"/>
   </p:sldIdLst>
   <p:sldSz cx="12192000" cy="6858000"/>
   <p:notesSz cx="6858000" cy="9144000"/>
@@ -279,7 +279,7 @@
           <a:p>
             <a:fld id="{1BC09191-4334-1F47-BEDE-1ACAF3EAB152}" type="datetimeFigureOut">
               <a:rPr lang="en-US" smtClean="0"/>
-              <a:t>4/7/26</a:t>
+              <a:t>8/3/2026</a:t>
             </a:fld>
             <a:endParaRPr lang="en-US"/>
           </a:p>
@@ -477,7 +477,7 @@
           <a:p>
             <a:fld id="{1BC09191-4334-1F47-BEDE-1ACAF3EAB152}" type="datetimeFigureOut">
               <a:rPr lang="en-US" smtClean="0"/>
-              <a:t>4/7/26</a:t>
+              <a:t>8/3/2026</a:t>
             </a:fld>
             <a:endParaRPr lang="en-US"/>
           </a:p>
@@ -685,7 +685,7 @@
           <a:p>
             <a:fld id="{1BC09191-4334-1F47-BEDE-1ACAF3EAB152}" type="datetimeFigureOut">
               <a:rPr lang="en-US" smtClean="0"/>
-              <a:t>4/7/26</a:t>
+              <a:t>8/3/2026</a:t>
             </a:fld>
             <a:endParaRPr lang="en-US"/>
           </a:p>
@@ -883,7 +883,7 @@
           <a:p>
             <a:fld id="{1BC09191-4334-1F47-BEDE-1ACAF3EAB152}" type="datetimeFigureOut">
               <a:rPr lang="en-US" smtClean="0"/>
-              <a:t>4/7/26</a:t>
+              <a:t>8/3/2026</a:t>
             </a:fld>
             <a:endParaRPr lang="en-US"/>
           </a:p>
@@ -1158,7 +1158,7 @@
           <a:p>
             <a:fld id="{1BC09191-4334-1F47-BEDE-1ACAF3EAB152}" type="datetimeFigureOut">
               <a:rPr lang="en-US" smtClean="0"/>
-              <a:t>4/7/26</a:t>
+              <a:t>8/3/2026</a:t>
             </a:fld>
             <a:endParaRPr lang="en-US"/>
           </a:p>
@@ -1423,7 +1423,7 @@
           <a:p>
             <a:fld id="{1BC09191-4334-1F47-BEDE-1ACAF3EAB152}" type="datetimeFigureOut">
               <a:rPr lang="en-US" smtClean="0"/>
-              <a:t>4/7/26</a:t>
+              <a:t>8/3/2026</a:t>
             </a:fld>
             <a:endParaRPr lang="en-US"/>
           </a:p>
@@ -1835,7 +1835,7 @@
           <a:p>
             <a:fld id="{1BC09191-4334-1F47-BEDE-1ACAF3EAB152}" type="datetimeFigureOut">
               <a:rPr lang="en-US" smtClean="0"/>
-              <a:t>4/7/26</a:t>
+              <a:t>8/3/2026</a:t>
             </a:fld>
             <a:endParaRPr lang="en-US"/>
           </a:p>
@@ -1976,7 +1976,7 @@
           <a:p>
             <a:fld id="{1BC09191-4334-1F47-BEDE-1ACAF3EAB152}" type="datetimeFigureOut">
               <a:rPr lang="en-US" smtClean="0"/>
-              <a:t>4/7/26</a:t>
+              <a:t>8/3/2026</a:t>
             </a:fld>
             <a:endParaRPr lang="en-US"/>
           </a:p>
@@ -2089,7 +2089,7 @@
           <a:p>
             <a:fld id="{1BC09191-4334-1F47-BEDE-1ACAF3EAB152}" type="datetimeFigureOut">
               <a:rPr lang="en-US" smtClean="0"/>
-              <a:t>4/7/26</a:t>
+              <a:t>8/3/2026</a:t>
             </a:fld>
             <a:endParaRPr lang="en-US"/>
           </a:p>
@@ -2400,7 +2400,7 @@
           <a:p>
             <a:fld id="{1BC09191-4334-1F47-BEDE-1ACAF3EAB152}" type="datetimeFigureOut">
               <a:rPr lang="en-US" smtClean="0"/>
-              <a:t>4/7/26</a:t>
+              <a:t>8/3/2026</a:t>
             </a:fld>
             <a:endParaRPr lang="en-US"/>
           </a:p>
@@ -2688,7 +2688,7 @@
           <a:p>
             <a:fld id="{1BC09191-4334-1F47-BEDE-1ACAF3EAB152}" type="datetimeFigureOut">
               <a:rPr lang="en-US" smtClean="0"/>
-              <a:t>4/7/26</a:t>
+              <a:t>8/3/2026</a:t>
             </a:fld>
             <a:endParaRPr lang="en-US"/>
           </a:p>
@@ -2929,7 +2929,7 @@
           <a:p>
             <a:fld id="{1BC09191-4334-1F47-BEDE-1ACAF3EAB152}" type="datetimeFigureOut">
               <a:rPr lang="en-US" smtClean="0"/>
-              <a:t>4/7/26</a:t>
+              <a:t>8/3/2026</a:t>
             </a:fld>
             <a:endParaRPr lang="en-US"/>
           </a:p>
@@ -13829,7 +13829,7 @@
             </a:pPr>
             <a:r>
               <a:rPr lang="en-US" sz="1400" dirty="0"/>
-              <a:t>Protect critical time-series data (energy usage, operation history, trends, PPD) against data loss on the controller by maintaining an up-to-date local copy.</a:t>
+              <a:t>Protect critical time-series data (history, meter, optime, trend, PPD) against data loss on the controller by maintaining an up-to-date local copy.</a:t>
             </a:r>
             <a:br>
               <a:rPr lang="en-US" sz="1400" dirty="0"/>
@@ -14020,36 +14020,9 @@
               <a:rPr lang="en-US" dirty="0"/>
               <a:t>Stores operational data in 5 SQLite databases: history, meter, optime, trend, ppd.</a:t>
             </a:r>
-          </a:p>
-          <a:p>
-            <a:pPr lvl="1">
-              <a:defRPr sz="1400"/>
-            </a:pPr>
-            <a:r>
+            <a:br>
               <a:rPr lang="en-US" dirty="0"/>
-              <a:t>Also stores snapshot files: </a:t>
-            </a:r>
-            <a:r>
-              <a:rPr lang="en-US" dirty="0" err="1"/>
-              <a:t>point_list.db</a:t>
-            </a:r>
-            <a:r>
-              <a:rPr lang="en-US" dirty="0"/>
-              <a:t>, </a:t>
-            </a:r>
-            <a:r>
-              <a:rPr lang="en-US" dirty="0" err="1"/>
-              <a:t>rent_stat.json</a:t>
-            </a:r>
-            <a:r>
-              <a:rPr lang="en-US" dirty="0"/>
-              <a:t>.</a:t>
-            </a:r>
-          </a:p>
-          <a:p>
-            <a:pPr>
-              <a:defRPr sz="1400"/>
-            </a:pPr>
+            </a:br>
             <a:endParaRPr lang="en-US" dirty="0"/>
           </a:p>
           <a:p>
@@ -19132,6 +19105,26 @@
 </file>
 
 <file path=customXml/item1.xml><?xml version="1.0" encoding="utf-8"?>
+<p:properties xmlns:p="http://schemas.microsoft.com/office/2006/metadata/properties" xmlns:xsi="http://www.w3.org/2001/XMLSchema-instance" xmlns:pc="http://schemas.microsoft.com/office/infopath/2007/PartnerControls">
+  <documentManagement>
+    <lcf76f155ced4ddcb4097134ff3c332f xmlns="7be2dbff-d50b-455f-9126-8c739bfa4d72">
+      <Terms xmlns="http://schemas.microsoft.com/office/infopath/2007/PartnerControls"/>
+    </lcf76f155ced4ddcb4097134ff3c332f>
+    <TaxCatchAll xmlns="dffcc4a2-be35-4275-a814-1eb1d6279ab1" xsi:nil="true"/>
+  </documentManagement>
+</p:properties>
+</file>
+
+<file path=customXml/item2.xml><?xml version="1.0" encoding="utf-8"?>
+<?mso-contentType ?>
+<FormTemplates xmlns="http://schemas.microsoft.com/sharepoint/v3/contenttype/forms">
+  <Display>DocumentLibraryForm</Display>
+  <Edit>DocumentLibraryForm</Edit>
+  <New>DocumentLibraryForm</New>
+</FormTemplates>
+</file>
+
+<file path=customXml/item3.xml><?xml version="1.0" encoding="utf-8"?>
 <ct:contentTypeSchema xmlns:ct="http://schemas.microsoft.com/office/2006/metadata/contentType" xmlns:ma="http://schemas.microsoft.com/office/2006/metadata/properties/metaAttributes" ct:_="" ma:_="" ma:contentTypeName="Document" ma:contentTypeID="0x010100628DFBB6E47DDB40821BC9F718E39974" ma:contentTypeVersion="15" ma:contentTypeDescription="Create a new document." ma:contentTypeScope="" ma:versionID="1d1077eabe4d2e0ec3bf3bcd9b1acc13">
   <xsd:schema xmlns:xsd="http://www.w3.org/2001/XMLSchema" xmlns:xs="http://www.w3.org/2001/XMLSchema" xmlns:p="http://schemas.microsoft.com/office/2006/metadata/properties" xmlns:ns2="7be2dbff-d50b-455f-9126-8c739bfa4d72" xmlns:ns3="dffcc4a2-be35-4275-a814-1eb1d6279ab1" targetNamespace="http://schemas.microsoft.com/office/2006/metadata/properties" ma:root="true" ma:fieldsID="f8409dac7c5838312ebf45b89701e920" ns2:_="" ns3:_="">
     <xsd:import namespace="7be2dbff-d50b-455f-9126-8c739bfa4d72"/>
@@ -19380,34 +19373,40 @@
 </ct:contentTypeSchema>
 </file>
 
-<file path=customXml/item2.xml><?xml version="1.0" encoding="utf-8"?>
-<?mso-contentType ?>
-<FormTemplates xmlns="http://schemas.microsoft.com/sharepoint/v3/contenttype/forms">
-  <Display>DocumentLibraryForm</Display>
-  <Edit>DocumentLibraryForm</Edit>
-  <New>DocumentLibraryForm</New>
-</FormTemplates>
-</file>
-
-<file path=customXml/item3.xml><?xml version="1.0" encoding="utf-8"?>
-<p:properties xmlns:p="http://schemas.microsoft.com/office/2006/metadata/properties" xmlns:xsi="http://www.w3.org/2001/XMLSchema-instance" xmlns:pc="http://schemas.microsoft.com/office/infopath/2007/PartnerControls">
-  <documentManagement>
-    <lcf76f155ced4ddcb4097134ff3c332f xmlns="7be2dbff-d50b-455f-9126-8c739bfa4d72">
-      <Terms xmlns="http://schemas.microsoft.com/office/infopath/2007/PartnerControls"/>
-    </lcf76f155ced4ddcb4097134ff3c332f>
-    <TaxCatchAll xmlns="dffcc4a2-be35-4275-a814-1eb1d6279ab1" xsi:nil="true"/>
-  </documentManagement>
-</p:properties>
-</file>
-
 <file path=customXml/itemProps1.xml><?xml version="1.0" encoding="utf-8"?>
-<ds:datastoreItem xmlns:ds="http://schemas.openxmlformats.org/officeDocument/2006/customXml" ds:itemID="{2C200E23-FE8C-4EB2-9A1F-E0CA78EEA244}"/>
+<ds:datastoreItem xmlns:ds="http://schemas.openxmlformats.org/officeDocument/2006/customXml" ds:itemID="{4000A5E7-0D79-4E8B-BD64-AC4CBC66B923}">
+  <ds:schemaRefs>
+    <ds:schemaRef ds:uri="http://schemas.microsoft.com/office/2006/metadata/properties"/>
+    <ds:schemaRef ds:uri="http://schemas.microsoft.com/office/infopath/2007/PartnerControls"/>
+    <ds:schemaRef ds:uri="7be2dbff-d50b-455f-9126-8c739bfa4d72"/>
+    <ds:schemaRef ds:uri="dffcc4a2-be35-4275-a814-1eb1d6279ab1"/>
+  </ds:schemaRefs>
+</ds:datastoreItem>
 </file>
 
 <file path=customXml/itemProps2.xml><?xml version="1.0" encoding="utf-8"?>
-<ds:datastoreItem xmlns:ds="http://schemas.openxmlformats.org/officeDocument/2006/customXml" ds:itemID="{8F396883-AD8F-4CE2-AB4B-E5FD89F6B925}"/>
+<ds:datastoreItem xmlns:ds="http://schemas.openxmlformats.org/officeDocument/2006/customXml" ds:itemID="{8F396883-AD8F-4CE2-AB4B-E5FD89F6B925}">
+  <ds:schemaRefs>
+    <ds:schemaRef ds:uri="http://schemas.microsoft.com/sharepoint/v3/contenttype/forms"/>
+  </ds:schemaRefs>
+</ds:datastoreItem>
 </file>
 
 <file path=customXml/itemProps3.xml><?xml version="1.0" encoding="utf-8"?>
-<ds:datastoreItem xmlns:ds="http://schemas.openxmlformats.org/officeDocument/2006/customXml" ds:itemID="{4000A5E7-0D79-4E8B-BD64-AC4CBC66B923}"/>
+<ds:datastoreItem xmlns:ds="http://schemas.openxmlformats.org/officeDocument/2006/customXml" ds:itemID="{2C200E23-FE8C-4EB2-9A1F-E0CA78EEA244}">
+  <ds:schemaRefs>
+    <ds:schemaRef ds:uri="http://schemas.microsoft.com/office/2006/metadata/contentType"/>
+    <ds:schemaRef ds:uri="http://schemas.microsoft.com/office/2006/metadata/properties/metaAttributes"/>
+    <ds:schemaRef ds:uri="http://www.w3.org/2001/XMLSchema"/>
+    <ds:schemaRef ds:uri="http://schemas.microsoft.com/office/2006/metadata/properties"/>
+    <ds:schemaRef ds:uri="7be2dbff-d50b-455f-9126-8c739bfa4d72"/>
+    <ds:schemaRef ds:uri="dffcc4a2-be35-4275-a814-1eb1d6279ab1"/>
+    <ds:schemaRef ds:uri="http://schemas.microsoft.com/office/2006/documentManagement/types"/>
+    <ds:schemaRef ds:uri="http://schemas.microsoft.com/office/infopath/2007/PartnerControls"/>
+    <ds:schemaRef ds:uri="http://schemas.openxmlformats.org/package/2006/metadata/core-properties"/>
+    <ds:schemaRef ds:uri="http://purl.org/dc/elements/1.1/"/>
+    <ds:schemaRef ds:uri="http://purl.org/dc/terms/"/>
+    <ds:schemaRef ds:uri="http://schemas.microsoft.com/internal/obd"/>
+  </ds:schemaRefs>
+</ds:datastoreItem>
 </file>
</xml_diff>